<commit_message>
Agrega presentación del proyecto de Fase 2
</commit_message>
<xml_diff>
--- a/Fase 2/Evidencias Proyecto/Presentación Proyecto.pptx
+++ b/Fase 2/Evidencias Proyecto/Presentación Proyecto.pptx
@@ -116,26 +116,26 @@
   <p:extLst>
     <p:ext uri="{521415D9-36F7-43E2-AB2F-B90AF26B5E84}">
       <p14:sectionLst xmlns:p14="http://schemas.microsoft.com/office/powerpoint/2010/main">
-        <p14:section name="Introducción" id="{88bb8843-e938-13d4-385c-95957fb5bc2f}">
+        <p14:section name="Introducción" id="{b3d8127a-d88a-e786-b320-6c4b07e1478c}">
           <p14:sldIdLst>
             <p14:sldId id="256"/>
             <p14:sldId id="257"/>
           </p14:sldIdLst>
         </p14:section>
-        <p14:section name="La solución" id="{4a688487-57a6-58b4-d5d7-301ea520f582}">
+        <p14:section name="La solución" id="{98960ce7-1f1e-615c-e722-7adab0b38b08}">
           <p14:sldIdLst>
             <p14:sldId id="258"/>
             <p14:sldId id="259"/>
           </p14:sldIdLst>
         </p14:section>
-        <p14:section name="Cómo funciona" id="{bcfae91e-ba1b-2e9a-218e-cf090d80a41f}">
+        <p14:section name="Cómo funciona" id="{b9066465-e4a1-34ee-4219-249cfc0bac25}">
           <p14:sldIdLst>
             <p14:sldId id="260"/>
             <p14:sldId id="261"/>
             <p14:sldId id="262"/>
           </p14:sldIdLst>
         </p14:section>
-        <p14:section name="Avance y próximos pasos" id="{95a1b55f-2e49-ae85-3e58-ba8af85d102d}">
+        <p14:section name="Avance y próximos pasos" id="{c86b3965-3c1e-c5eb-ea86-e8f3ac49ad06}">
           <p14:sldIdLst>
             <p14:sldId id="263"/>
             <p14:sldId id="264"/>
@@ -203,6 +203,16 @@
             <c:bubble3D val="0"/>
             <c:spPr>
               <a:solidFill>
+                <a:srgbClr val="E0A43A"/>
+              </a:solidFill>
+              <a:effectLst/>
+            </c:spPr>
+          </c:dPt>
+          <c:dPt>
+            <c:idx val="2"/>
+            <c:bubble3D val="0"/>
+            <c:spPr>
+              <a:solidFill>
                 <a:srgbClr val="DCEDEA"/>
               </a:solidFill>
               <a:effectLst/>
@@ -259,6 +269,31 @@
               <c:showPercent val="0"/>
               <c:showBubbleSize val="0"/>
             </c:dLbl>
+            <c:dLbl>
+              <c:idx val="2"/>
+              <c:numFmt formatCode="General" sourceLinked="0"/>
+              <c:spPr/>
+              <c:txPr>
+                <a:bodyPr/>
+                <a:lstStyle/>
+                <a:p>
+                  <a:pPr>
+                    <a:defRPr sz="1200" b="0" i="0" u="none" strike="noStrike">
+                      <a:solidFill>
+                        <a:srgbClr val="000000"/>
+                      </a:solidFill>
+                      <a:latin typeface="Arial"/>
+                    </a:defRPr>
+                  </a:pPr>
+                </a:p>
+              </c:txPr>
+              <c:showLegendKey val="0"/>
+              <c:showVal val="0"/>
+              <c:showCatName val="0"/>
+              <c:showSerName val="0"/>
+              <c:showPercent val="0"/>
+              <c:showBubbleSize val="0"/>
+            </c:dLbl>
             <c:numFmt formatCode="General" sourceLinked="0"/>
             <c:txPr>
               <a:bodyPr/>
@@ -284,13 +319,16 @@
           </c:dLbls>
           <c:cat>
             <c:strRef>
-              <c:f>Sheet1!$A$2:$A$3</c:f>
+              <c:f>Sheet1!$A$2:$A$4</c:f>
               <c:strCache>
-                <c:ptCount val="2"/>
+                <c:ptCount val="3"/>
                 <c:pt idx="0">
                   <c:v>Implementadas</c:v>
                 </c:pt>
                 <c:pt idx="1">
+                  <c:v>En desarrollo</c:v>
+                </c:pt>
+                <c:pt idx="2">
                   <c:v>Pendientes</c:v>
                 </c:pt>
               </c:strCache>
@@ -298,13 +336,16 @@
           </c:cat>
           <c:val>
             <c:numRef>
-              <c:f>Sheet1!$B$2:$B$3</c:f>
+              <c:f>Sheet1!$B$2:$B$4</c:f>
               <c:numCache>
-                <c:ptCount val="2"/>
+                <c:ptCount val="3"/>
                 <c:pt idx="0">
-                  <c:v>5</c:v>
+                  <c:v>4</c:v>
                 </c:pt>
                 <c:pt idx="1">
+                  <c:v>1</c:v>
+                </c:pt>
+                <c:pt idx="2">
                   <c:v>3</c:v>
                 </c:pt>
               </c:numCache>
@@ -1261,7 +1302,7 @@
           <a:p>
             <a:r>
               <a:rPr lang="en-US" dirty="0"/>
-              <a:t>El componente de IA no decide por el banco: alerta y explica. Detecta anomalías por deudor, tendencias de rechazo y sugiere reglas nuevas que el analista puede aprobar. Si la IA falla, el informe se procesa igual.</a:t>
+              <a:t>El componente de IA está en desarrollo; esto es lo que hará. No decidirá por el banco: alertará y explicará. Detectará anomalías por deudor y tendencias de rechazo, y sugerirá reglas nuevas que el analista podrá aprobar. Si la IA falla, el informe se procesará igual.</a:t>
             </a:r>
             <a:endParaRPr lang="en-US" dirty="0"/>
           </a:p>
@@ -1437,7 +1478,7 @@
           <a:p>
             <a:r>
               <a:rPr lang="en-US" dirty="0"/>
-              <a:t>Al cierre de la Fase 2 tenemos cinco de ocho etapas funcionando: recepción, extracción, ETL, bandeja de excepciones e IA, respaldadas por 132 pruebas automatizadas. Quedan para la Fase 3 el cruce con clientes, la respuesta a la TGR y el dashboard.</a:t>
+              <a:t>Al cierre de la Fase 2 tenemos cuatro de ocho etapas funcionando: recepción, extracción, ETL y bandeja de excepciones, respaldadas por 116 pruebas automatizadas. La IA analítica está en desarrollo. Quedan para la Fase 3 el cruce con clientes, la respuesta a la TGR y el dashboard.</a:t>
             </a:r>
             <a:endParaRPr lang="en-US" dirty="0"/>
           </a:p>
@@ -1525,7 +1566,7 @@
           <a:p>
             <a:r>
               <a:rPr lang="en-US" dirty="0"/>
-              <a:t>En la Fase 3 cerramos el ciclo de valor para el banco: el cruce con clientes y la regla de 0,5 UTM, la respuesta a la TGR con avisos a clientes, el dashboard con roles y, por último, las pruebas integrales y la entrega.</a:t>
+              <a:t>En la Fase 3 cerramos el ciclo de valor para el banco: el cruce con clientes y la regla de 0,5 UTM, la respuesta a la TGR con avisos a clientes, el dashboard con roles y, por último, terminar la IA analítica junto con las pruebas integrales y la entrega.</a:t>
             </a:r>
             <a:endParaRPr lang="en-US" dirty="0"/>
           </a:p>
@@ -5712,14 +5753,52 @@
       </p:pic>
       <p:sp>
         <p:nvSpPr>
-          <p:cNvPr id="5" name="Texto IA"/>
+          <p:cNvPr id="5" name="Etiqueta en desarrollo"/>
           <p:cNvSpPr txBox="1"/>
           <p:nvPr/>
         </p:nvSpPr>
         <p:spPr>
           <a:xfrm>
-            <a:off x="685800" y="2651760"/>
-            <a:ext cx="2194560" cy="1645920"/>
+            <a:off x="731520" y="3931920"/>
+            <a:ext cx="2103120" cy="365760"/>
+          </a:xfrm>
+          <a:prstGeom prst="rect">
+            <a:avLst/>
+          </a:prstGeom>
+          <a:solidFill>
+            <a:srgbClr val="E0A43A"/>
+          </a:solidFill>
+          <a:ln/>
+        </p:spPr>
+        <p:txBody>
+          <a:bodyPr wrap="square" lIns="0" tIns="0" rIns="0" bIns="0" rtlCol="0" anchor="ctr"/>
+          <a:lstStyle/>
+          <a:p>
+            <a:pPr algn="ctr" indent="0" marL="0">
+              <a:buNone/>
+            </a:pPr>
+            <a:r>
+              <a:rPr lang="en-US" sz="1200" b="1" spc="200" kern="0" dirty="0">
+                <a:solidFill>
+                  <a:schemeClr val="tx2"/>
+                </a:solidFill>
+              </a:rPr>
+              <a:t>EN DESARROLLO</a:t>
+            </a:r>
+            <a:endParaRPr lang="en-US" sz="1200" dirty="0"/>
+          </a:p>
+        </p:txBody>
+      </p:sp>
+      <p:sp>
+        <p:nvSpPr>
+          <p:cNvPr id="6" name="Texto IA"/>
+          <p:cNvSpPr txBox="1"/>
+          <p:nvPr/>
+        </p:nvSpPr>
+        <p:spPr>
+          <a:xfrm>
+            <a:off x="685800" y="2606040"/>
+            <a:ext cx="2194560" cy="1188720"/>
           </a:xfrm>
           <a:prstGeom prst="rect">
             <a:avLst/>
@@ -5740,7 +5819,7 @@
                   <a:schemeClr val="bg1"/>
                 </a:solidFill>
               </a:rPr>
-              <a:t>Compara cada informe con el historial de casos y alerta lo que se sale de lo habitual.</a:t>
+              <a:t>Comparará cada informe con el historial de casos y alertará lo que se salga de lo habitual.</a:t>
             </a:r>
             <a:endParaRPr lang="en-US" sz="1400" dirty="0"/>
           </a:p>
@@ -5748,7 +5827,7 @@
       </p:sp>
       <p:sp>
         <p:nvSpPr>
-          <p:cNvPr id="6" name="Anomalías por deudor círculo"/>
+          <p:cNvPr id="7" name="Anomalías por deudor círculo"/>
           <p:cNvSpPr/>
           <p:nvPr/>
         </p:nvSpPr>
@@ -5768,7 +5847,7 @@
       </p:sp>
       <p:pic>
         <p:nvPicPr>
-          <p:cNvPr id="7" name="Anomalías por deudor icono" descr="preencoded.png">    </p:cNvPr>
+          <p:cNvPr id="8" name="Anomalías por deudor icono" descr="preencoded.png">    </p:cNvPr>
           <p:cNvPicPr>
             <a:picLocks noChangeAspect="1"/>
           </p:cNvPicPr>
@@ -5792,7 +5871,7 @@
       </p:pic>
       <p:sp>
         <p:nvSpPr>
-          <p:cNvPr id="8" name="IA Anomalías por deudor"/>
+          <p:cNvPr id="9" name="IA Anomalías por deudor"/>
           <p:cNvSpPr txBox="1"/>
           <p:nvPr/>
         </p:nvSpPr>
@@ -5842,7 +5921,7 @@
       </p:sp>
       <p:sp>
         <p:nvSpPr>
-          <p:cNvPr id="9" name="Tendencias de rechazo círculo"/>
+          <p:cNvPr id="10" name="Tendencias de rechazo círculo"/>
           <p:cNvSpPr/>
           <p:nvPr/>
         </p:nvSpPr>
@@ -5862,7 +5941,7 @@
       </p:sp>
       <p:pic>
         <p:nvPicPr>
-          <p:cNvPr id="10" name="Tendencias de rechazo icono" descr="preencoded.png">    </p:cNvPr>
+          <p:cNvPr id="11" name="Tendencias de rechazo icono" descr="preencoded.png">    </p:cNvPr>
           <p:cNvPicPr>
             <a:picLocks noChangeAspect="1"/>
           </p:cNvPicPr>
@@ -5886,7 +5965,7 @@
       </p:pic>
       <p:sp>
         <p:nvSpPr>
-          <p:cNvPr id="11" name="IA Tendencias de rechazo"/>
+          <p:cNvPr id="12" name="IA Tendencias de rechazo"/>
           <p:cNvSpPr txBox="1"/>
           <p:nvPr/>
         </p:nvSpPr>
@@ -5928,7 +6007,7 @@
                   <a:schemeClr val="tx1"/>
                 </a:solidFill>
               </a:rPr>
-              <a:t>Detecta informes con más errores que lo normal y señala el motivo que domina.</a:t>
+              <a:t>Detectará informes con más errores que lo normal y el motivo que domina.</a:t>
             </a:r>
             <a:endParaRPr lang="en-US" sz="1500" dirty="0"/>
           </a:p>
@@ -5936,7 +6015,7 @@
       </p:sp>
       <p:sp>
         <p:nvSpPr>
-          <p:cNvPr id="12" name="Reglas sugeridas círculo"/>
+          <p:cNvPr id="13" name="Reglas sugeridas círculo"/>
           <p:cNvSpPr/>
           <p:nvPr/>
         </p:nvSpPr>
@@ -5956,7 +6035,7 @@
       </p:sp>
       <p:pic>
         <p:nvPicPr>
-          <p:cNvPr id="13" name="Reglas sugeridas icono" descr="preencoded.png">    </p:cNvPr>
+          <p:cNvPr id="14" name="Reglas sugeridas icono" descr="preencoded.png">    </p:cNvPr>
           <p:cNvPicPr>
             <a:picLocks noChangeAspect="1"/>
           </p:cNvPicPr>
@@ -5980,7 +6059,7 @@
       </p:pic>
       <p:sp>
         <p:nvSpPr>
-          <p:cNvPr id="14" name="IA Reglas sugeridas"/>
+          <p:cNvPr id="15" name="IA Reglas sugeridas"/>
           <p:cNvSpPr txBox="1"/>
           <p:nvPr/>
         </p:nvSpPr>
@@ -6022,7 +6101,7 @@
                   <a:schemeClr val="tx1"/>
                 </a:solidFill>
               </a:rPr>
-              <a:t>Propone nuevas validaciones; si el analista las aprueba, se aplican desde el siguiente informe.</a:t>
+              <a:t>Propondrá nuevas validaciones; si el analista las aprueba, se aplicarán desde el siguiente informe.</a:t>
             </a:r>
             <a:endParaRPr lang="en-US" sz="1500" dirty="0"/>
           </a:p>
@@ -6769,7 +6848,7 @@
                 <a:ea typeface="Cambria" pitchFamily="34" charset="-122"/>
                 <a:cs typeface="Cambria" pitchFamily="34" charset="-120"/>
               </a:rPr>
-              <a:t>5 de 8</a:t>
+              <a:t>4 de 8</a:t>
             </a:r>
             <a:endParaRPr lang="en-US" sz="2800" dirty="0"/>
           </a:p>
@@ -6822,7 +6901,7 @@
                 <a:ea typeface="Cambria" pitchFamily="34" charset="-122"/>
                 <a:cs typeface="Cambria" pitchFamily="34" charset="-120"/>
               </a:rPr>
-              <a:t>132</a:t>
+              <a:t>116</a:t>
             </a:r>
             <a:pPr algn="ctr" indent="0" marL="0">
               <a:buNone/>
@@ -7310,10 +7389,10 @@
             <a:r>
               <a:rPr lang="en-US" sz="1200" b="1" dirty="0">
                 <a:solidFill>
-                  <a:schemeClr val="accent1"/>
-                </a:solidFill>
-              </a:rPr>
-              <a:t>Listo</a:t>
+                  <a:schemeClr val="accent2"/>
+                </a:solidFill>
+              </a:rPr>
+              <a:t>En curso</a:t>
             </a:r>
             <a:endParaRPr lang="en-US" sz="1200" dirty="0"/>
           </a:p>
@@ -8360,7 +8439,7 @@
                   <a:schemeClr val="tx2"/>
                 </a:solidFill>
               </a:rPr>
-              <a:t>Pruebas y cierre</a:t>
+              <a:t>IA y cierre</a:t>
             </a:r>
             <a:endParaRPr lang="en-US" sz="1500" dirty="0"/>
           </a:p>
@@ -8396,7 +8475,7 @@
                   <a:schemeClr val="tx1"/>
                 </a:solidFill>
               </a:rPr>
-              <a:t>Pruebas integrales de punta a punta, documentación y entrega final.</a:t>
+              <a:t>Terminar la IA analítica, pruebas de punta a punta y entrega final.</a:t>
             </a:r>
             <a:endParaRPr lang="en-US" sz="1200" dirty="0"/>
           </a:p>

</xml_diff>